<commit_message>
Initial commit of Vermikendra presentation assets
</commit_message>
<xml_diff>
--- a/Vermikendra_Complete_7_Slides_Presentation.pptx
+++ b/Vermikendra_Complete_7_Slides_Presentation.pptx
@@ -3096,7 +3096,7 @@
       <p:grpSpPr/>
       <p:pic>
         <p:nvPicPr>
-          <p:cNvPr id="2" name="Picture 1" descr="slide_1_cover_complete_1789389305410.jpg"/>
+          <p:cNvPr id="2" name="Picture 1" descr="slide_1_cover_master.jpg"/>
           <p:cNvPicPr>
             <a:picLocks noChangeAspect="1"/>
           </p:cNvPicPr>
@@ -3138,7 +3138,7 @@
       <p:grpSpPr/>
       <p:pic>
         <p:nvPicPr>
-          <p:cNvPr id="2" name="Picture 1" descr="slide_2_image2_style_master.jpg"/>
+          <p:cNvPr id="2" name="Picture 1" descr="slide_2_pictorial_text_1789389752199.jpg"/>
           <p:cNvPicPr>
             <a:picLocks noChangeAspect="1"/>
           </p:cNvPicPr>
@@ -3180,7 +3180,7 @@
       <p:grpSpPr/>
       <p:pic>
         <p:nvPicPr>
-          <p:cNvPr id="2" name="Picture 1" descr="slide_3_research_journal_definitive.jpg"/>
+          <p:cNvPr id="2" name="Picture 1" descr="slide_3_research_journal_master.jpg"/>
           <p:cNvPicPr>
             <a:picLocks noChangeAspect="1"/>
           </p:cNvPicPr>

</xml_diff>